<commit_message>
docs(apresentacao): integra WebSocket no roteiro e slide 8 (espelho do server)
Espelha as mesmas atualizacoes do commit ff3a1e7 no server:

- docs/ROTEIRO_DEMO.md: checklist + Fluxo 3.5 (terminal lateral mostrando
  WebSocket ao vivo via node scripts/test-ws-battle.mjs no server)
- docs/SLIDES_CONTENT.md slide 8: titulo "Layout da batalha + streaming
  WebSocket", bullets com useBattleStream + maquina de estados
- apresentacao/build/gerar.js + .pptx: slide 8 regenerado

WebSocket de batalha esta funcionando em prod desde o fix de Node 20
de algumas horas atras.
</commit_message>
<xml_diff>
--- a/apresentacao/AutoSoccer_Apresentacao.pptx
+++ b/apresentacao/AutoSoccer_Apresentacao.pptx
@@ -13425,7 +13425,7 @@
                 <a:ea typeface="Arial" pitchFamily="34" charset="-122"/>
                 <a:cs typeface="Arial" pitchFamily="34" charset="-120"/>
               </a:rPr>
-              <a:t>LAYOUT DA BATALHA</a:t>
+              <a:t>LAYOUT DA BATALHA + STREAMING WEBSOCKET</a:t>
             </a:r>
             <a:endParaRPr lang="en-US" sz="3000" dirty="0"/>
           </a:p>
@@ -13552,6 +13552,27 @@
                 <a:cs typeface="Arial" pitchFamily="34" charset="-120"/>
               </a:rPr>
               <a:t>Maquina de estados: idle -&gt; connecting -&gt; streaming -&gt; finished (com fallback local de setInterval se WS falhar)</a:t>
+            </a:r>
+            <a:endParaRPr lang="en-US" sz="1600" dirty="0"/>
+          </a:p>
+          <a:p>
+            <a:pPr algn="l" marL="228600" indent="-228600">
+              <a:spcAft>
+                <a:spcPts val="1000"/>
+              </a:spcAft>
+              <a:buSzPct val="100000"/>
+              <a:buChar char="▪"/>
+            </a:pPr>
+            <a:r>
+              <a:rPr lang="en-US" sz="1600" dirty="0">
+                <a:solidFill>
+                  <a:srgbClr val="E2E8F0"/>
+                </a:solidFill>
+                <a:latin typeface="Arial" pitchFamily="34" charset="0"/>
+                <a:ea typeface="Arial" pitchFamily="34" charset="-122"/>
+                <a:cs typeface="Arial" pitchFamily="34" charset="-120"/>
+              </a:rPr>
+              <a:t>Validavel sem o front: node scripts/test-ws-battle.mjs no server mostra os 12 turnos chegando ao vivo no terminal</a:t>
             </a:r>
             <a:endParaRPr lang="en-US" sz="1600" dirty="0"/>
           </a:p>

</xml_diff>